<commit_message>
added a page about arry expansion and filter
</commit_message>
<xml_diff>
--- a/Slides/JavaScript/07 - Loops.pptx
+++ b/Slides/JavaScript/07 - Loops.pptx
@@ -5,10 +5,10 @@
     <p:sldMasterId id="2147483648" r:id="rId4"/>
   </p:sldMasterIdLst>
   <p:notesMasterIdLst>
-    <p:notesMasterId r:id="rId12"/>
+    <p:notesMasterId r:id="rId13"/>
   </p:notesMasterIdLst>
   <p:handoutMasterIdLst>
-    <p:handoutMasterId r:id="rId13"/>
+    <p:handoutMasterId r:id="rId14"/>
   </p:handoutMasterIdLst>
   <p:sldIdLst>
     <p:sldId id="263" r:id="rId5"/>
@@ -18,11 +18,12 @@
     <p:sldId id="480" r:id="rId9"/>
     <p:sldId id="483" r:id="rId10"/>
     <p:sldId id="530" r:id="rId11"/>
+    <p:sldId id="531" r:id="rId12"/>
   </p:sldIdLst>
   <p:sldSz cx="12192000" cy="6858000"/>
   <p:notesSz cx="6645275" cy="9775825"/>
   <p:custDataLst>
-    <p:tags r:id="rId14"/>
+    <p:tags r:id="rId15"/>
   </p:custDataLst>
   <p:defaultTextStyle>
     <a:defPPr>
@@ -243,7 +244,7 @@
             <a:fld id="{86D088FE-3E68-47FE-8BA4-634CD34BABBC}" type="datetimeFigureOut">
               <a:rPr lang="en-GB" smtClean="0"/>
               <a:pPr/>
-              <a:t>08/09/2022</a:t>
+              <a:t>22/09/2026</a:t>
             </a:fld>
             <a:endParaRPr lang="en-GB"/>
           </a:p>
@@ -415,7 +416,7 @@
             <a:fld id="{1D6B66C6-1E92-0F4E-A300-9D4ED1F0C23F}" type="datetimeFigureOut">
               <a:rPr lang="en-GB" smtClean="0"/>
               <a:pPr/>
-              <a:t>08/09/2022</a:t>
+              <a:t>22/09/2026</a:t>
             </a:fld>
             <a:endParaRPr lang="en-GB"/>
           </a:p>
@@ -2031,13 +2032,13 @@
           <p:nvPr userDrawn="1"/>
         </p:nvPicPr>
         <p:blipFill>
-          <a:blip r:embed="rId3">
+          <a:blip>
             <a:extLst>
               <a:ext uri="{28A0092B-C50C-407E-A947-70E740481C1C}">
                 <a14:useLocalDpi xmlns:a14="http://schemas.microsoft.com/office/drawing/2010/main" val="0"/>
               </a:ext>
               <a:ext uri="{96DAC541-7B7A-43D3-8B79-37D633B846F1}">
-                <asvg:svgBlip xmlns:asvg="http://schemas.microsoft.com/office/drawing/2016/SVG/main" r:embed="rId4"/>
+                <asvg:svgBlip xmlns:asvg="http://schemas.microsoft.com/office/drawing/2016/SVG/main" r:embed="rId3"/>
               </a:ext>
             </a:extLst>
           </a:blip>
@@ -10418,13 +10419,13 @@
           <p:nvPr userDrawn="1"/>
         </p:nvPicPr>
         <p:blipFill>
-          <a:blip r:embed="rId3">
+          <a:blip>
             <a:extLst>
               <a:ext uri="{28A0092B-C50C-407E-A947-70E740481C1C}">
                 <a14:useLocalDpi xmlns:a14="http://schemas.microsoft.com/office/drawing/2010/main" val="0"/>
               </a:ext>
               <a:ext uri="{96DAC541-7B7A-43D3-8B79-37D633B846F1}">
-                <asvg:svgBlip xmlns:asvg="http://schemas.microsoft.com/office/drawing/2016/SVG/main" r:embed="rId4"/>
+                <asvg:svgBlip xmlns:asvg="http://schemas.microsoft.com/office/drawing/2016/SVG/main" r:embed="rId3"/>
               </a:ext>
             </a:extLst>
           </a:blip>
@@ -17595,13 +17596,13 @@
           <p:nvPr userDrawn="1"/>
         </p:nvPicPr>
         <p:blipFill>
-          <a:blip r:embed="rId3">
+          <a:blip>
             <a:extLst>
               <a:ext uri="{28A0092B-C50C-407E-A947-70E740481C1C}">
                 <a14:useLocalDpi xmlns:a14="http://schemas.microsoft.com/office/drawing/2010/main" val="0"/>
               </a:ext>
               <a:ext uri="{96DAC541-7B7A-43D3-8B79-37D633B846F1}">
-                <asvg:svgBlip xmlns:asvg="http://schemas.microsoft.com/office/drawing/2016/SVG/main" r:embed="rId4"/>
+                <asvg:svgBlip xmlns:asvg="http://schemas.microsoft.com/office/drawing/2016/SVG/main" r:embed="rId3"/>
               </a:ext>
             </a:extLst>
           </a:blip>
@@ -20222,13 +20223,13 @@
           <p:nvPr userDrawn="1"/>
         </p:nvPicPr>
         <p:blipFill>
-          <a:blip r:embed="rId3">
+          <a:blip>
             <a:extLst>
               <a:ext uri="{28A0092B-C50C-407E-A947-70E740481C1C}">
                 <a14:useLocalDpi xmlns:a14="http://schemas.microsoft.com/office/drawing/2010/main" val="0"/>
               </a:ext>
               <a:ext uri="{96DAC541-7B7A-43D3-8B79-37D633B846F1}">
-                <asvg:svgBlip xmlns:asvg="http://schemas.microsoft.com/office/drawing/2016/SVG/main" r:embed="rId4"/>
+                <asvg:svgBlip xmlns:asvg="http://schemas.microsoft.com/office/drawing/2016/SVG/main" r:embed="rId3"/>
               </a:ext>
             </a:extLst>
           </a:blip>
@@ -21929,13 +21930,13 @@
           <p:nvPr userDrawn="1"/>
         </p:nvPicPr>
         <p:blipFill>
-          <a:blip r:embed="rId3">
+          <a:blip>
             <a:extLst>
               <a:ext uri="{28A0092B-C50C-407E-A947-70E740481C1C}">
                 <a14:useLocalDpi xmlns:a14="http://schemas.microsoft.com/office/drawing/2010/main" val="0"/>
               </a:ext>
               <a:ext uri="{96DAC541-7B7A-43D3-8B79-37D633B846F1}">
-                <asvg:svgBlip xmlns:asvg="http://schemas.microsoft.com/office/drawing/2016/SVG/main" r:embed="rId4"/>
+                <asvg:svgBlip xmlns:asvg="http://schemas.microsoft.com/office/drawing/2016/SVG/main" r:embed="rId3"/>
               </a:ext>
             </a:extLst>
           </a:blip>
@@ -28659,6 +28660,793 @@
     <p:extLst>
       <p:ext uri="{BB962C8B-B14F-4D97-AF65-F5344CB8AC3E}">
         <p14:creationId xmlns:p14="http://schemas.microsoft.com/office/powerpoint/2010/main" val="887486449"/>
+      </p:ext>
+    </p:extLst>
+  </p:cSld>
+  <p:clrMapOvr>
+    <a:masterClrMapping/>
+  </p:clrMapOvr>
+</p:sld>
+</file>
+
+<file path=ppt/slides/slide8.xml><?xml version="1.0" encoding="utf-8"?>
+<p:sld xmlns:a="http://schemas.openxmlformats.org/drawingml/2006/main" xmlns:r="http://schemas.openxmlformats.org/officeDocument/2006/relationships" xmlns:p="http://schemas.openxmlformats.org/presentationml/2006/main">
+  <p:cSld>
+    <p:spTree>
+      <p:nvGrpSpPr>
+        <p:cNvPr id="1" name=""/>
+        <p:cNvGrpSpPr/>
+        <p:nvPr/>
+      </p:nvGrpSpPr>
+      <p:grpSpPr>
+        <a:xfrm>
+          <a:off x="0" y="0"/>
+          <a:ext cx="0" cy="0"/>
+          <a:chOff x="0" y="0"/>
+          <a:chExt cx="0" cy="0"/>
+        </a:xfrm>
+      </p:grpSpPr>
+      <p:sp>
+        <p:nvSpPr>
+          <p:cNvPr id="2" name="Text Placeholder 1">
+            <a:extLst>
+              <a:ext uri="{FF2B5EF4-FFF2-40B4-BE49-F238E27FC236}">
+                <a16:creationId xmlns:a16="http://schemas.microsoft.com/office/drawing/2014/main" id="{0813BEE7-A72B-2B34-BAF1-AE25D0884D8A}"/>
+              </a:ext>
+            </a:extLst>
+          </p:cNvPr>
+          <p:cNvSpPr>
+            <a:spLocks noGrp="1"/>
+          </p:cNvSpPr>
+          <p:nvPr>
+            <p:ph type="body" sz="quarter" idx="10"/>
+          </p:nvPr>
+        </p:nvSpPr>
+        <p:spPr/>
+        <p:txBody>
+          <a:bodyPr/>
+          <a:lstStyle/>
+          <a:p>
+            <a:r>
+              <a:rPr lang="en-US" dirty="0"/>
+              <a:t>More about Arrays!</a:t>
+            </a:r>
+            <a:endParaRPr lang="en-GB" dirty="0"/>
+          </a:p>
+        </p:txBody>
+      </p:sp>
+      <p:sp>
+        <p:nvSpPr>
+          <p:cNvPr id="9" name="TextBox 8">
+            <a:extLst>
+              <a:ext uri="{FF2B5EF4-FFF2-40B4-BE49-F238E27FC236}">
+                <a16:creationId xmlns:a16="http://schemas.microsoft.com/office/drawing/2014/main" id="{5CB894E7-9A38-44FF-160C-0616DA7C5167}"/>
+              </a:ext>
+            </a:extLst>
+          </p:cNvPr>
+          <p:cNvSpPr txBox="1"/>
+          <p:nvPr/>
+        </p:nvSpPr>
+        <p:spPr>
+          <a:xfrm>
+            <a:off x="4698122" y="464919"/>
+            <a:ext cx="6873767" cy="4481611"/>
+          </a:xfrm>
+          <a:prstGeom prst="rect">
+            <a:avLst/>
+          </a:prstGeom>
+          <a:noFill/>
+        </p:spPr>
+        <p:txBody>
+          <a:bodyPr wrap="square">
+            <a:spAutoFit/>
+          </a:bodyPr>
+          <a:lstStyle/>
+          <a:p>
+            <a:pPr>
+              <a:lnSpc>
+                <a:spcPct val="150000"/>
+              </a:lnSpc>
+              <a:buNone/>
+            </a:pPr>
+            <a:r>
+              <a:rPr lang="en-GB" sz="1600" b="1" dirty="0">
+                <a:solidFill>
+                  <a:srgbClr val="0000FF"/>
+                </a:solidFill>
+                <a:effectLst/>
+                <a:latin typeface="Cascadia Mono" panose="020B0609020000020004" pitchFamily="49" charset="0"/>
+              </a:rPr>
+              <a:t>let</a:t>
+            </a:r>
+            <a:r>
+              <a:rPr lang="en-GB" sz="1600" b="1" dirty="0">
+                <a:solidFill>
+                  <a:srgbClr val="000000"/>
+                </a:solidFill>
+                <a:effectLst/>
+                <a:latin typeface="Cascadia Mono" panose="020B0609020000020004" pitchFamily="49" charset="0"/>
+              </a:rPr>
+              <a:t> </a:t>
+            </a:r>
+            <a:r>
+              <a:rPr lang="en-GB" sz="1600" b="1" dirty="0">
+                <a:solidFill>
+                  <a:srgbClr val="1F377F"/>
+                </a:solidFill>
+                <a:effectLst/>
+                <a:latin typeface="Cascadia Mono" panose="020B0609020000020004" pitchFamily="49" charset="0"/>
+              </a:rPr>
+              <a:t>names</a:t>
+            </a:r>
+            <a:r>
+              <a:rPr lang="en-GB" sz="1600" b="1" dirty="0">
+                <a:solidFill>
+                  <a:srgbClr val="000000"/>
+                </a:solidFill>
+                <a:effectLst/>
+                <a:latin typeface="Cascadia Mono" panose="020B0609020000020004" pitchFamily="49" charset="0"/>
+              </a:rPr>
+              <a:t>=</a:t>
+            </a:r>
+            <a:r>
+              <a:rPr lang="en-GB" sz="1600" b="1" dirty="0">
+                <a:solidFill>
+                  <a:srgbClr val="A31515"/>
+                </a:solidFill>
+                <a:effectLst/>
+                <a:latin typeface="Cascadia Mono" panose="020B0609020000020004" pitchFamily="49" charset="0"/>
+              </a:rPr>
+              <a:t>"Johnny, Jane, Bobby, Alice"</a:t>
+            </a:r>
+            <a:r>
+              <a:rPr lang="en-GB" sz="1600" b="1" dirty="0">
+                <a:solidFill>
+                  <a:srgbClr val="000000"/>
+                </a:solidFill>
+                <a:effectLst/>
+                <a:latin typeface="Cascadia Mono" panose="020B0609020000020004" pitchFamily="49" charset="0"/>
+              </a:rPr>
+              <a:t>;</a:t>
+            </a:r>
+          </a:p>
+          <a:p>
+            <a:pPr>
+              <a:lnSpc>
+                <a:spcPct val="150000"/>
+              </a:lnSpc>
+              <a:buNone/>
+            </a:pPr>
+            <a:r>
+              <a:rPr lang="en-GB" sz="1600" b="1">
+                <a:solidFill>
+                  <a:srgbClr val="2B91AF"/>
+                </a:solidFill>
+                <a:effectLst/>
+                <a:latin typeface="Cascadia Mono" panose="020B0609020000020004" pitchFamily="49" charset="0"/>
+              </a:rPr>
+              <a:t>console</a:t>
+            </a:r>
+            <a:r>
+              <a:rPr lang="en-GB" sz="1600" b="1" dirty="0">
+                <a:solidFill>
+                  <a:srgbClr val="000000"/>
+                </a:solidFill>
+                <a:effectLst/>
+                <a:latin typeface="Cascadia Mono" panose="020B0609020000020004" pitchFamily="49" charset="0"/>
+              </a:rPr>
+              <a:t>.</a:t>
+            </a:r>
+            <a:r>
+              <a:rPr lang="en-GB" sz="1600" b="1" dirty="0">
+                <a:solidFill>
+                  <a:srgbClr val="74531F"/>
+                </a:solidFill>
+                <a:effectLst/>
+                <a:latin typeface="Cascadia Mono" panose="020B0609020000020004" pitchFamily="49" charset="0"/>
+              </a:rPr>
+              <a:t>log</a:t>
+            </a:r>
+            <a:r>
+              <a:rPr lang="en-GB" sz="1600" b="1" dirty="0">
+                <a:solidFill>
+                  <a:srgbClr val="000000"/>
+                </a:solidFill>
+                <a:effectLst/>
+                <a:latin typeface="Cascadia Mono" panose="020B0609020000020004" pitchFamily="49" charset="0"/>
+              </a:rPr>
+              <a:t>(</a:t>
+            </a:r>
+            <a:r>
+              <a:rPr lang="en-GB" sz="1600" b="1" dirty="0">
+                <a:solidFill>
+                  <a:srgbClr val="1F377F"/>
+                </a:solidFill>
+                <a:effectLst/>
+                <a:latin typeface="Cascadia Mono" panose="020B0609020000020004" pitchFamily="49" charset="0"/>
+              </a:rPr>
+              <a:t>names</a:t>
+            </a:r>
+            <a:r>
+              <a:rPr lang="en-GB" sz="1600" b="1" dirty="0">
+                <a:solidFill>
+                  <a:srgbClr val="000000"/>
+                </a:solidFill>
+                <a:effectLst/>
+                <a:latin typeface="Cascadia Mono" panose="020B0609020000020004" pitchFamily="49" charset="0"/>
+              </a:rPr>
+              <a:t>);</a:t>
+            </a:r>
+          </a:p>
+          <a:p>
+            <a:pPr>
+              <a:lnSpc>
+                <a:spcPct val="200000"/>
+              </a:lnSpc>
+              <a:buNone/>
+            </a:pPr>
+            <a:endParaRPr lang="en-GB" sz="1600" b="1" dirty="0">
+              <a:solidFill>
+                <a:srgbClr val="000000"/>
+              </a:solidFill>
+              <a:effectLst/>
+              <a:latin typeface="Cascadia Mono" panose="020B0609020000020004" pitchFamily="49" charset="0"/>
+            </a:endParaRPr>
+          </a:p>
+          <a:p>
+            <a:pPr>
+              <a:lnSpc>
+                <a:spcPct val="150000"/>
+              </a:lnSpc>
+              <a:buNone/>
+            </a:pPr>
+            <a:r>
+              <a:rPr lang="en-GB" sz="1600" b="1" dirty="0">
+                <a:solidFill>
+                  <a:srgbClr val="1F377F"/>
+                </a:solidFill>
+                <a:effectLst/>
+                <a:latin typeface="Cascadia Mono" panose="020B0609020000020004" pitchFamily="49" charset="0"/>
+              </a:rPr>
+              <a:t>names</a:t>
+            </a:r>
+            <a:r>
+              <a:rPr lang="en-GB" sz="1600" b="1" dirty="0">
+                <a:solidFill>
+                  <a:srgbClr val="000000"/>
+                </a:solidFill>
+                <a:effectLst/>
+                <a:latin typeface="Cascadia Mono" panose="020B0609020000020004" pitchFamily="49" charset="0"/>
+              </a:rPr>
+              <a:t> = </a:t>
+            </a:r>
+            <a:r>
+              <a:rPr lang="en-GB" sz="1600" b="1" dirty="0" err="1">
+                <a:solidFill>
+                  <a:srgbClr val="1F377F"/>
+                </a:solidFill>
+                <a:effectLst/>
+                <a:latin typeface="Cascadia Mono" panose="020B0609020000020004" pitchFamily="49" charset="0"/>
+              </a:rPr>
+              <a:t>names</a:t>
+            </a:r>
+            <a:r>
+              <a:rPr lang="en-GB" sz="1600" b="1" dirty="0" err="1">
+                <a:solidFill>
+                  <a:srgbClr val="000000"/>
+                </a:solidFill>
+                <a:effectLst/>
+                <a:latin typeface="Cascadia Mono" panose="020B0609020000020004" pitchFamily="49" charset="0"/>
+              </a:rPr>
+              <a:t>.</a:t>
+            </a:r>
+            <a:r>
+              <a:rPr lang="en-GB" sz="1600" b="1" dirty="0" err="1">
+                <a:solidFill>
+                  <a:srgbClr val="74531F"/>
+                </a:solidFill>
+                <a:effectLst/>
+                <a:latin typeface="Cascadia Mono" panose="020B0609020000020004" pitchFamily="49" charset="0"/>
+              </a:rPr>
+              <a:t>split</a:t>
+            </a:r>
+            <a:r>
+              <a:rPr lang="en-GB" sz="1600" b="1" dirty="0">
+                <a:solidFill>
+                  <a:srgbClr val="000000"/>
+                </a:solidFill>
+                <a:effectLst/>
+                <a:latin typeface="Cascadia Mono" panose="020B0609020000020004" pitchFamily="49" charset="0"/>
+              </a:rPr>
+              <a:t>(</a:t>
+            </a:r>
+            <a:r>
+              <a:rPr lang="en-GB" sz="1600" b="1" dirty="0">
+                <a:solidFill>
+                  <a:srgbClr val="A31515"/>
+                </a:solidFill>
+                <a:effectLst/>
+                <a:latin typeface="Cascadia Mono" panose="020B0609020000020004" pitchFamily="49" charset="0"/>
+              </a:rPr>
+              <a:t>','</a:t>
+            </a:r>
+            <a:r>
+              <a:rPr lang="en-GB" sz="1600" b="1" dirty="0">
+                <a:solidFill>
+                  <a:srgbClr val="000000"/>
+                </a:solidFill>
+                <a:effectLst/>
+                <a:latin typeface="Cascadia Mono" panose="020B0609020000020004" pitchFamily="49" charset="0"/>
+              </a:rPr>
+              <a:t>);</a:t>
+            </a:r>
+          </a:p>
+          <a:p>
+            <a:pPr>
+              <a:lnSpc>
+                <a:spcPct val="150000"/>
+              </a:lnSpc>
+              <a:buNone/>
+            </a:pPr>
+            <a:r>
+              <a:rPr lang="en-GB" sz="1600" b="1" dirty="0">
+                <a:solidFill>
+                  <a:srgbClr val="2B91AF"/>
+                </a:solidFill>
+                <a:effectLst/>
+                <a:latin typeface="Cascadia Mono" panose="020B0609020000020004" pitchFamily="49" charset="0"/>
+              </a:rPr>
+              <a:t>console</a:t>
+            </a:r>
+            <a:r>
+              <a:rPr lang="en-GB" sz="1600" b="1" dirty="0">
+                <a:solidFill>
+                  <a:srgbClr val="000000"/>
+                </a:solidFill>
+                <a:effectLst/>
+                <a:latin typeface="Cascadia Mono" panose="020B0609020000020004" pitchFamily="49" charset="0"/>
+              </a:rPr>
+              <a:t>.</a:t>
+            </a:r>
+            <a:r>
+              <a:rPr lang="en-GB" sz="1600" b="1" dirty="0">
+                <a:solidFill>
+                  <a:srgbClr val="74531F"/>
+                </a:solidFill>
+                <a:effectLst/>
+                <a:latin typeface="Cascadia Mono" panose="020B0609020000020004" pitchFamily="49" charset="0"/>
+              </a:rPr>
+              <a:t>log</a:t>
+            </a:r>
+            <a:r>
+              <a:rPr lang="en-GB" sz="1600" b="1" dirty="0">
+                <a:solidFill>
+                  <a:srgbClr val="000000"/>
+                </a:solidFill>
+                <a:effectLst/>
+                <a:latin typeface="Cascadia Mono" panose="020B0609020000020004" pitchFamily="49" charset="0"/>
+              </a:rPr>
+              <a:t>(</a:t>
+            </a:r>
+            <a:r>
+              <a:rPr lang="en-GB" sz="1600" b="1" dirty="0">
+                <a:solidFill>
+                  <a:srgbClr val="1F377F"/>
+                </a:solidFill>
+                <a:effectLst/>
+                <a:latin typeface="Cascadia Mono" panose="020B0609020000020004" pitchFamily="49" charset="0"/>
+              </a:rPr>
+              <a:t>names</a:t>
+            </a:r>
+            <a:r>
+              <a:rPr lang="en-GB" sz="1600" b="1" dirty="0">
+                <a:solidFill>
+                  <a:srgbClr val="000000"/>
+                </a:solidFill>
+                <a:effectLst/>
+                <a:latin typeface="Cascadia Mono" panose="020B0609020000020004" pitchFamily="49" charset="0"/>
+              </a:rPr>
+              <a:t>);</a:t>
+            </a:r>
+          </a:p>
+          <a:p>
+            <a:pPr>
+              <a:lnSpc>
+                <a:spcPct val="200000"/>
+              </a:lnSpc>
+              <a:buNone/>
+            </a:pPr>
+            <a:endParaRPr lang="en-GB" sz="1600" b="1" dirty="0">
+              <a:solidFill>
+                <a:srgbClr val="000000"/>
+              </a:solidFill>
+              <a:effectLst/>
+              <a:latin typeface="Cascadia Mono" panose="020B0609020000020004" pitchFamily="49" charset="0"/>
+            </a:endParaRPr>
+          </a:p>
+          <a:p>
+            <a:pPr>
+              <a:lnSpc>
+                <a:spcPct val="150000"/>
+              </a:lnSpc>
+              <a:buNone/>
+            </a:pPr>
+            <a:r>
+              <a:rPr lang="en-GB" sz="1600" b="1" dirty="0">
+                <a:solidFill>
+                  <a:srgbClr val="1F377F"/>
+                </a:solidFill>
+                <a:effectLst/>
+                <a:latin typeface="Cascadia Mono" panose="020B0609020000020004" pitchFamily="49" charset="0"/>
+              </a:rPr>
+              <a:t>names</a:t>
+            </a:r>
+            <a:r>
+              <a:rPr lang="en-GB" sz="1600" b="1" dirty="0">
+                <a:solidFill>
+                  <a:srgbClr val="000000"/>
+                </a:solidFill>
+                <a:effectLst/>
+                <a:latin typeface="Cascadia Mono" panose="020B0609020000020004" pitchFamily="49" charset="0"/>
+              </a:rPr>
+              <a:t> = [...</a:t>
+            </a:r>
+            <a:r>
+              <a:rPr lang="en-GB" sz="1600" b="1" dirty="0" err="1">
+                <a:solidFill>
+                  <a:srgbClr val="1F377F"/>
+                </a:solidFill>
+                <a:effectLst/>
+                <a:latin typeface="Cascadia Mono" panose="020B0609020000020004" pitchFamily="49" charset="0"/>
+              </a:rPr>
+              <a:t>names</a:t>
+            </a:r>
+            <a:r>
+              <a:rPr lang="en-GB" sz="1600" b="1" dirty="0" err="1">
+                <a:solidFill>
+                  <a:srgbClr val="000000"/>
+                </a:solidFill>
+                <a:effectLst/>
+                <a:latin typeface="Cascadia Mono" panose="020B0609020000020004" pitchFamily="49" charset="0"/>
+              </a:rPr>
+              <a:t>,</a:t>
+            </a:r>
+            <a:r>
+              <a:rPr lang="en-GB" sz="1600" b="1" dirty="0" err="1">
+                <a:solidFill>
+                  <a:srgbClr val="A31515"/>
+                </a:solidFill>
+                <a:effectLst/>
+                <a:latin typeface="Cascadia Mono" panose="020B0609020000020004" pitchFamily="49" charset="0"/>
+              </a:rPr>
+              <a:t>'Mike</a:t>
+            </a:r>
+            <a:r>
+              <a:rPr lang="en-GB" sz="1600" b="1" dirty="0">
+                <a:solidFill>
+                  <a:srgbClr val="A31515"/>
+                </a:solidFill>
+                <a:effectLst/>
+                <a:latin typeface="Cascadia Mono" panose="020B0609020000020004" pitchFamily="49" charset="0"/>
+              </a:rPr>
+              <a:t>'</a:t>
+            </a:r>
+            <a:r>
+              <a:rPr lang="en-GB" sz="1600" b="1" dirty="0">
+                <a:solidFill>
+                  <a:srgbClr val="000000"/>
+                </a:solidFill>
+                <a:effectLst/>
+                <a:latin typeface="Cascadia Mono" panose="020B0609020000020004" pitchFamily="49" charset="0"/>
+              </a:rPr>
+              <a:t>];</a:t>
+            </a:r>
+          </a:p>
+          <a:p>
+            <a:pPr>
+              <a:lnSpc>
+                <a:spcPct val="150000"/>
+              </a:lnSpc>
+              <a:buNone/>
+            </a:pPr>
+            <a:r>
+              <a:rPr lang="en-GB" sz="1600" b="1" dirty="0">
+                <a:solidFill>
+                  <a:srgbClr val="2B91AF"/>
+                </a:solidFill>
+                <a:effectLst/>
+                <a:latin typeface="Cascadia Mono" panose="020B0609020000020004" pitchFamily="49" charset="0"/>
+              </a:rPr>
+              <a:t>console</a:t>
+            </a:r>
+            <a:r>
+              <a:rPr lang="en-GB" sz="1600" b="1" dirty="0">
+                <a:solidFill>
+                  <a:srgbClr val="000000"/>
+                </a:solidFill>
+                <a:effectLst/>
+                <a:latin typeface="Cascadia Mono" panose="020B0609020000020004" pitchFamily="49" charset="0"/>
+              </a:rPr>
+              <a:t>.</a:t>
+            </a:r>
+            <a:r>
+              <a:rPr lang="en-GB" sz="1600" b="1" dirty="0">
+                <a:solidFill>
+                  <a:srgbClr val="74531F"/>
+                </a:solidFill>
+                <a:effectLst/>
+                <a:latin typeface="Cascadia Mono" panose="020B0609020000020004" pitchFamily="49" charset="0"/>
+              </a:rPr>
+              <a:t>log</a:t>
+            </a:r>
+            <a:r>
+              <a:rPr lang="en-GB" sz="1600" b="1" dirty="0">
+                <a:solidFill>
+                  <a:srgbClr val="000000"/>
+                </a:solidFill>
+                <a:effectLst/>
+                <a:latin typeface="Cascadia Mono" panose="020B0609020000020004" pitchFamily="49" charset="0"/>
+              </a:rPr>
+              <a:t>(</a:t>
+            </a:r>
+            <a:r>
+              <a:rPr lang="en-GB" sz="1600" b="1" dirty="0">
+                <a:solidFill>
+                  <a:srgbClr val="1F377F"/>
+                </a:solidFill>
+                <a:effectLst/>
+                <a:latin typeface="Cascadia Mono" panose="020B0609020000020004" pitchFamily="49" charset="0"/>
+              </a:rPr>
+              <a:t>names</a:t>
+            </a:r>
+            <a:r>
+              <a:rPr lang="en-GB" sz="1600" b="1" dirty="0">
+                <a:solidFill>
+                  <a:srgbClr val="000000"/>
+                </a:solidFill>
+                <a:effectLst/>
+                <a:latin typeface="Cascadia Mono" panose="020B0609020000020004" pitchFamily="49" charset="0"/>
+              </a:rPr>
+              <a:t>);</a:t>
+            </a:r>
+          </a:p>
+          <a:p>
+            <a:pPr>
+              <a:lnSpc>
+                <a:spcPct val="200000"/>
+              </a:lnSpc>
+              <a:buNone/>
+            </a:pPr>
+            <a:endParaRPr lang="en-GB" sz="1600" b="1" dirty="0">
+              <a:solidFill>
+                <a:srgbClr val="000000"/>
+              </a:solidFill>
+              <a:effectLst/>
+              <a:latin typeface="Cascadia Mono" panose="020B0609020000020004" pitchFamily="49" charset="0"/>
+            </a:endParaRPr>
+          </a:p>
+          <a:p>
+            <a:pPr>
+              <a:lnSpc>
+                <a:spcPct val="150000"/>
+              </a:lnSpc>
+              <a:buNone/>
+            </a:pPr>
+            <a:r>
+              <a:rPr lang="en-GB" sz="1600" b="1" dirty="0">
+                <a:solidFill>
+                  <a:srgbClr val="0000FF"/>
+                </a:solidFill>
+                <a:effectLst/>
+                <a:latin typeface="Cascadia Mono" panose="020B0609020000020004" pitchFamily="49" charset="0"/>
+              </a:rPr>
+              <a:t>let</a:t>
+            </a:r>
+            <a:r>
+              <a:rPr lang="en-GB" sz="1600" b="1" dirty="0">
+                <a:solidFill>
+                  <a:srgbClr val="000000"/>
+                </a:solidFill>
+                <a:effectLst/>
+                <a:latin typeface="Cascadia Mono" panose="020B0609020000020004" pitchFamily="49" charset="0"/>
+              </a:rPr>
+              <a:t> </a:t>
+            </a:r>
+            <a:r>
+              <a:rPr lang="en-GB" sz="1600" b="1" dirty="0" err="1">
+                <a:solidFill>
+                  <a:srgbClr val="1F377F"/>
+                </a:solidFill>
+                <a:effectLst/>
+                <a:latin typeface="Cascadia Mono" panose="020B0609020000020004" pitchFamily="49" charset="0"/>
+              </a:rPr>
+              <a:t>shortNames</a:t>
+            </a:r>
+            <a:r>
+              <a:rPr lang="en-GB" sz="1600" b="1" dirty="0">
+                <a:solidFill>
+                  <a:srgbClr val="000000"/>
+                </a:solidFill>
+                <a:effectLst/>
+                <a:latin typeface="Cascadia Mono" panose="020B0609020000020004" pitchFamily="49" charset="0"/>
+              </a:rPr>
+              <a:t> = </a:t>
+            </a:r>
+            <a:r>
+              <a:rPr lang="en-GB" sz="1600" b="1" dirty="0" err="1">
+                <a:solidFill>
+                  <a:srgbClr val="1F377F"/>
+                </a:solidFill>
+                <a:effectLst/>
+                <a:latin typeface="Cascadia Mono" panose="020B0609020000020004" pitchFamily="49" charset="0"/>
+              </a:rPr>
+              <a:t>names</a:t>
+            </a:r>
+            <a:r>
+              <a:rPr lang="en-GB" sz="1600" b="1" dirty="0" err="1">
+                <a:solidFill>
+                  <a:srgbClr val="000000"/>
+                </a:solidFill>
+                <a:effectLst/>
+                <a:latin typeface="Cascadia Mono" panose="020B0609020000020004" pitchFamily="49" charset="0"/>
+              </a:rPr>
+              <a:t>.</a:t>
+            </a:r>
+            <a:r>
+              <a:rPr lang="en-GB" sz="1600" b="1" dirty="0" err="1">
+                <a:solidFill>
+                  <a:srgbClr val="74531F"/>
+                </a:solidFill>
+                <a:effectLst/>
+                <a:latin typeface="Cascadia Mono" panose="020B0609020000020004" pitchFamily="49" charset="0"/>
+              </a:rPr>
+              <a:t>filter</a:t>
+            </a:r>
+            <a:r>
+              <a:rPr lang="en-GB" sz="1600" b="1" dirty="0">
+                <a:solidFill>
+                  <a:srgbClr val="000000"/>
+                </a:solidFill>
+                <a:effectLst/>
+                <a:latin typeface="Cascadia Mono" panose="020B0609020000020004" pitchFamily="49" charset="0"/>
+              </a:rPr>
+              <a:t>(</a:t>
+            </a:r>
+            <a:r>
+              <a:rPr lang="en-GB" sz="1600" b="1" dirty="0">
+                <a:solidFill>
+                  <a:srgbClr val="1F377F"/>
+                </a:solidFill>
+                <a:effectLst/>
+                <a:latin typeface="Cascadia Mono" panose="020B0609020000020004" pitchFamily="49" charset="0"/>
+              </a:rPr>
+              <a:t>name</a:t>
+            </a:r>
+            <a:r>
+              <a:rPr lang="en-GB" sz="1600" b="1" dirty="0">
+                <a:solidFill>
+                  <a:srgbClr val="000000"/>
+                </a:solidFill>
+                <a:effectLst/>
+                <a:latin typeface="Cascadia Mono" panose="020B0609020000020004" pitchFamily="49" charset="0"/>
+              </a:rPr>
+              <a:t> =&gt; </a:t>
+            </a:r>
+            <a:r>
+              <a:rPr lang="en-GB" sz="1600" b="1" dirty="0" err="1">
+                <a:solidFill>
+                  <a:srgbClr val="1F377F"/>
+                </a:solidFill>
+                <a:effectLst/>
+                <a:latin typeface="Cascadia Mono" panose="020B0609020000020004" pitchFamily="49" charset="0"/>
+              </a:rPr>
+              <a:t>name</a:t>
+            </a:r>
+            <a:r>
+              <a:rPr lang="en-GB" sz="1600" b="1" dirty="0" err="1">
+                <a:solidFill>
+                  <a:srgbClr val="000000"/>
+                </a:solidFill>
+                <a:effectLst/>
+                <a:latin typeface="Cascadia Mono" panose="020B0609020000020004" pitchFamily="49" charset="0"/>
+              </a:rPr>
+              <a:t>.</a:t>
+            </a:r>
+            <a:r>
+              <a:rPr lang="en-GB" sz="1600" b="1" dirty="0" err="1">
+                <a:solidFill>
+                  <a:srgbClr val="1F377F"/>
+                </a:solidFill>
+                <a:effectLst/>
+                <a:latin typeface="Cascadia Mono" panose="020B0609020000020004" pitchFamily="49" charset="0"/>
+              </a:rPr>
+              <a:t>length</a:t>
+            </a:r>
+            <a:r>
+              <a:rPr lang="en-GB" sz="1600" b="1" dirty="0">
+                <a:solidFill>
+                  <a:srgbClr val="000000"/>
+                </a:solidFill>
+                <a:effectLst/>
+                <a:latin typeface="Cascadia Mono" panose="020B0609020000020004" pitchFamily="49" charset="0"/>
+              </a:rPr>
+              <a:t> &lt; 6);</a:t>
+            </a:r>
+          </a:p>
+          <a:p>
+            <a:pPr>
+              <a:lnSpc>
+                <a:spcPct val="150000"/>
+              </a:lnSpc>
+              <a:buNone/>
+            </a:pPr>
+            <a:r>
+              <a:rPr lang="en-GB" sz="1600" b="1" dirty="0">
+                <a:solidFill>
+                  <a:srgbClr val="2B91AF"/>
+                </a:solidFill>
+                <a:effectLst/>
+                <a:latin typeface="Cascadia Mono" panose="020B0609020000020004" pitchFamily="49" charset="0"/>
+              </a:rPr>
+              <a:t>console</a:t>
+            </a:r>
+            <a:r>
+              <a:rPr lang="en-GB" sz="1600" b="1" dirty="0">
+                <a:solidFill>
+                  <a:srgbClr val="000000"/>
+                </a:solidFill>
+                <a:effectLst/>
+                <a:latin typeface="Cascadia Mono" panose="020B0609020000020004" pitchFamily="49" charset="0"/>
+              </a:rPr>
+              <a:t>.</a:t>
+            </a:r>
+            <a:r>
+              <a:rPr lang="en-GB" sz="1600" b="1" dirty="0">
+                <a:solidFill>
+                  <a:srgbClr val="74531F"/>
+                </a:solidFill>
+                <a:effectLst/>
+                <a:latin typeface="Cascadia Mono" panose="020B0609020000020004" pitchFamily="49" charset="0"/>
+              </a:rPr>
+              <a:t>log</a:t>
+            </a:r>
+            <a:r>
+              <a:rPr lang="en-GB" sz="1600" b="1" dirty="0">
+                <a:solidFill>
+                  <a:srgbClr val="000000"/>
+                </a:solidFill>
+                <a:effectLst/>
+                <a:latin typeface="Cascadia Mono" panose="020B0609020000020004" pitchFamily="49" charset="0"/>
+              </a:rPr>
+              <a:t>(</a:t>
+            </a:r>
+            <a:r>
+              <a:rPr lang="en-GB" sz="1600" b="1" dirty="0" err="1">
+                <a:solidFill>
+                  <a:srgbClr val="1F377F"/>
+                </a:solidFill>
+                <a:effectLst/>
+                <a:latin typeface="Cascadia Mono" panose="020B0609020000020004" pitchFamily="49" charset="0"/>
+              </a:rPr>
+              <a:t>shortNames</a:t>
+            </a:r>
+            <a:r>
+              <a:rPr lang="en-GB" sz="1600" b="1" dirty="0">
+                <a:solidFill>
+                  <a:srgbClr val="000000"/>
+                </a:solidFill>
+                <a:effectLst/>
+                <a:latin typeface="Cascadia Mono" panose="020B0609020000020004" pitchFamily="49" charset="0"/>
+              </a:rPr>
+              <a:t>);</a:t>
+            </a:r>
+          </a:p>
+        </p:txBody>
+      </p:sp>
+    </p:spTree>
+    <p:extLst>
+      <p:ext uri="{BB962C8B-B14F-4D97-AF65-F5344CB8AC3E}">
+        <p14:creationId xmlns:p14="http://schemas.microsoft.com/office/powerpoint/2010/main" val="2909985128"/>
       </p:ext>
     </p:extLst>
   </p:cSld>
@@ -29476,12 +30264,15 @@
 </file>
 
 <file path=customXml/item1.xml><?xml version="1.0" encoding="utf-8"?>
-<?mso-contentType ?>
-<FormTemplates xmlns="http://schemas.microsoft.com/sharepoint/v3/contenttype/forms">
-  <Display>DocumentLibraryForm</Display>
-  <Edit>DocumentLibraryForm</Edit>
-  <New>DocumentLibraryForm</New>
-</FormTemplates>
+<p:properties xmlns:p="http://schemas.microsoft.com/office/2006/metadata/properties" xmlns:xsi="http://www.w3.org/2001/XMLSchema-instance" xmlns:pc="http://schemas.microsoft.com/office/infopath/2007/PartnerControls">
+  <documentManagement>
+    <BookTypeField0 xmlns="B42EA499-AA80-4ED5-9ED5-37A17D3EB549">
+      <Terms xmlns="http://schemas.microsoft.com/office/infopath/2007/PartnerControls"/>
+    </BookTypeField0>
+    <IsBuildFile xmlns="B42EA499-AA80-4ED5-9ED5-37A17D3EB549" xsi:nil="true"/>
+    <SequenceNumber xmlns="B42EA499-AA80-4ED5-9ED5-37A17D3EB549" xsi:nil="true"/>
+  </documentManagement>
+</p:properties>
 </file>
 
 <file path=customXml/item2.xml><?xml version="1.0" encoding="utf-8"?>
@@ -29625,21 +30416,20 @@
 </file>
 
 <file path=customXml/item3.xml><?xml version="1.0" encoding="utf-8"?>
-<p:properties xmlns:p="http://schemas.microsoft.com/office/2006/metadata/properties" xmlns:xsi="http://www.w3.org/2001/XMLSchema-instance" xmlns:pc="http://schemas.microsoft.com/office/infopath/2007/PartnerControls">
-  <documentManagement>
-    <BookTypeField0 xmlns="B42EA499-AA80-4ED5-9ED5-37A17D3EB549">
-      <Terms xmlns="http://schemas.microsoft.com/office/infopath/2007/PartnerControls"/>
-    </BookTypeField0>
-    <IsBuildFile xmlns="B42EA499-AA80-4ED5-9ED5-37A17D3EB549" xsi:nil="true"/>
-    <SequenceNumber xmlns="B42EA499-AA80-4ED5-9ED5-37A17D3EB549" xsi:nil="true"/>
-  </documentManagement>
-</p:properties>
+<?mso-contentType ?>
+<FormTemplates xmlns="http://schemas.microsoft.com/sharepoint/v3/contenttype/forms">
+  <Display>DocumentLibraryForm</Display>
+  <Edit>DocumentLibraryForm</Edit>
+  <New>DocumentLibraryForm</New>
+</FormTemplates>
 </file>
 
 <file path=customXml/itemProps1.xml><?xml version="1.0" encoding="utf-8"?>
-<ds:datastoreItem xmlns:ds="http://schemas.openxmlformats.org/officeDocument/2006/customXml" ds:itemID="{052FB353-EBD8-45CB-9AA3-814402799036}">
+<ds:datastoreItem xmlns:ds="http://schemas.openxmlformats.org/officeDocument/2006/customXml" ds:itemID="{19A0C0D3-996A-423F-9079-5792F3E6029B}">
   <ds:schemaRefs>
-    <ds:schemaRef ds:uri="http://schemas.microsoft.com/sharepoint/v3/contenttype/forms"/>
+    <ds:schemaRef ds:uri="http://schemas.microsoft.com/office/2006/metadata/properties"/>
+    <ds:schemaRef ds:uri="http://schemas.microsoft.com/office/infopath/2007/PartnerControls"/>
+    <ds:schemaRef ds:uri="B42EA499-AA80-4ED5-9ED5-37A17D3EB549"/>
   </ds:schemaRefs>
 </ds:datastoreItem>
 </file>
@@ -29663,11 +30453,9 @@
 </file>
 
 <file path=customXml/itemProps3.xml><?xml version="1.0" encoding="utf-8"?>
-<ds:datastoreItem xmlns:ds="http://schemas.openxmlformats.org/officeDocument/2006/customXml" ds:itemID="{19A0C0D3-996A-423F-9079-5792F3E6029B}">
+<ds:datastoreItem xmlns:ds="http://schemas.openxmlformats.org/officeDocument/2006/customXml" ds:itemID="{052FB353-EBD8-45CB-9AA3-814402799036}">
   <ds:schemaRefs>
-    <ds:schemaRef ds:uri="http://schemas.microsoft.com/office/2006/metadata/properties"/>
-    <ds:schemaRef ds:uri="http://schemas.microsoft.com/office/infopath/2007/PartnerControls"/>
-    <ds:schemaRef ds:uri="B42EA499-AA80-4ED5-9ED5-37A17D3EB549"/>
+    <ds:schemaRef ds:uri="http://schemas.microsoft.com/sharepoint/v3/contenttype/forms"/>
   </ds:schemaRefs>
 </ds:datastoreItem>
 </file>
</xml_diff>